<commit_message>
fix(collab): sync images as data URLs instead of local blob URLs + E16
</commit_message>
<xml_diff>
--- a/e2e/collab/fixtures/collab-3slides.pptx
+++ b/e2e/collab/fixtures/collab-3slides.pptx
@@ -104,6 +104,28 @@
           </a:p>
         </p:txBody>
       </p:sp>
+      <p:pic>
+        <p:nvPicPr>
+          <p:cNvPr id="3" name="e2e-pic"/>
+          <p:cNvPicPr/>
+          <p:nvPr/>
+        </p:nvPicPr>
+        <p:blipFill>
+          <a:blip r:embed="rId2"/>
+          <a:stretch>
+            <a:fillRect/>
+          </a:stretch>
+        </p:blipFill>
+        <p:spPr>
+          <a:xfrm>
+            <a:off x="914400" y="3200400"/>
+            <a:ext cx="914400" cy="914400"/>
+          </a:xfrm>
+          <a:prstGeom prst="rect">
+            <a:avLst/>
+          </a:prstGeom>
+        </p:spPr>
+      </p:pic>
     </p:spTree>
   </p:cSld>
 </p:sld>

</xml_diff>

<commit_message>
test(collab): Q3 deterministic E18, Q4 browser E16 on 3-image fixture + msedge project, Q5 ydoc size measurement
</commit_message>
<xml_diff>
--- a/e2e/collab/fixtures/collab-3slides.pptx
+++ b/e2e/collab/fixtures/collab-3slides.pptx
@@ -106,7 +106,7 @@
       </p:sp>
       <p:pic>
         <p:nvPicPr>
-          <p:cNvPr id="3" name="e2e-pic"/>
+          <p:cNvPr id="3" name="e2e-pic1"/>
           <p:cNvPicPr/>
           <p:nvPr/>
         </p:nvPicPr>
@@ -119,6 +119,28 @@
         <p:spPr>
           <a:xfrm>
             <a:off x="914400" y="3200400"/>
+            <a:ext cx="914400" cy="914400"/>
+          </a:xfrm>
+          <a:prstGeom prst="rect">
+            <a:avLst/>
+          </a:prstGeom>
+        </p:spPr>
+      </p:pic>
+      <p:pic>
+        <p:nvPicPr>
+          <p:cNvPr id="4" name="e2e-pic2"/>
+          <p:cNvPicPr/>
+          <p:nvPr/>
+        </p:nvPicPr>
+        <p:blipFill>
+          <a:blip r:embed="rId3"/>
+          <a:stretch>
+            <a:fillRect/>
+          </a:stretch>
+        </p:blipFill>
+        <p:spPr>
+          <a:xfrm>
+            <a:off x="1914400" y="3200400"/>
             <a:ext cx="914400" cy="914400"/>
           </a:xfrm>
           <a:prstGeom prst="rect">
@@ -175,6 +197,28 @@
           </a:p>
         </p:txBody>
       </p:sp>
+      <p:pic>
+        <p:nvPicPr>
+          <p:cNvPr id="3" name="e2e-pic1"/>
+          <p:cNvPicPr/>
+          <p:nvPr/>
+        </p:nvPicPr>
+        <p:blipFill>
+          <a:blip r:embed="rId2"/>
+          <a:stretch>
+            <a:fillRect/>
+          </a:stretch>
+        </p:blipFill>
+        <p:spPr>
+          <a:xfrm>
+            <a:off x="914400" y="3200400"/>
+            <a:ext cx="914400" cy="914400"/>
+          </a:xfrm>
+          <a:prstGeom prst="rect">
+            <a:avLst/>
+          </a:prstGeom>
+        </p:spPr>
+      </p:pic>
     </p:spTree>
   </p:cSld>
 </p:sld>

</xml_diff>